<commit_message>
Say on the contract slide that the platform can forward SSO tokens
The authentication note covered only the key a developer types beside
the URL, which leaves out the half that matters to an agent doing its
own authorization: the platform can authenticate as whoever is signed
in to it, so per-user permissions on the agent server keep working.
Both modes now sit side by side, with the realm/audience requirement
and the "cache on the claims, not the token text" warning that a
re-minted token implies.

Also top-aligns the deck's text boxes. pptxgenjs centres them
vertically by default, so two columns whose text ran to different
line counts did not start on the same line.

Co-Authored-By: Claude Opus 5 <noreply@anthropic.com>
Claude-Session: https://claude.ai/code/session_01VyfDhoCrPdfZc3muLByrEB
</commit_message>
<xml_diff>
--- a/presentation/sprint-demo.pptx
+++ b/presentation/sprint-demo.pptx
@@ -783,10 +783,15 @@
           <a:p>
             <a:r>
               <a:rPr lang="en-US" dirty="0"/>
-              <a:t>約 1 分鐘。
+              <a:t>約 1.5 分鐘。
 重點一句話：只有 chat endpoint 是必須的，而且它就是一個標準的 OpenAI compatible chat completions endpoint。大部分 agent 前面本來就有一個，所以你今天其實就可以被 evaluate。
 skills endpoint 是選配的，它讓系統知道你身上現在有哪些 skill 檔案。
-另外強調：這是兩個各自獨立的絕對 URL，我們不會幫你組路徑，你要放在不同 host、不同 gateway 後面都可以。</a:t>
+這是兩個各自獨立的絕對 URL，我們不會幫你組路徑，你要放在不同 host、不同 gateway 後面都可以。
+下面那塊 authentication 想特別講：你的 server 要不要驗證，系統沒有意見，兩種都支援。但如果你需要驗，我們可以送兩種東西過去——
+一種是開發者自己填的 API key（Bearer，或你指定的 header 名稱）；
+另一種是把「當下登入這個系統的那個人」的 SSO token 直接 forward 給你。第二種是重點：它是唯一會告訴你「是誰在問」的模式，所以如果你在自己的 agent server 上已經做了 per-user 的權限控制，是可以直接接上來的，不用為了這個平台開一個共用的後門帳號。
+要注意的是 realm 跟 audience 要對得起來（同 realm 不代表同 aud），而且 token 在長時間的 run 中會被重新簽發，所以不要用 token 字串本身當 cache key，要用 claims。
+兩者可以並存：某個 agent 有自己填 key 的話，那把 key 優先，你永遠只會收到一個 Authorization header。</a:t>
             </a:r>
             <a:endParaRPr lang="en-US" dirty="0"/>
           </a:p>
@@ -1733,7 +1738,7 @@
           <a:ln/>
         </p:spPr>
         <p:txBody>
-          <a:bodyPr wrap="square" lIns="0" tIns="0" rIns="0" bIns="0" rtlCol="0" anchor="ctr"/>
+          <a:bodyPr wrap="square" lIns="0" tIns="0" rIns="0" bIns="0" rtlCol="0" anchor="t"/>
           <a:lstStyle/>
           <a:p>
             <a:pPr indent="0" marL="0">
@@ -1772,7 +1777,7 @@
           <a:ln/>
         </p:spPr>
         <p:txBody>
-          <a:bodyPr wrap="square" lIns="0" tIns="0" rIns="0" bIns="0" rtlCol="0" anchor="ctr"/>
+          <a:bodyPr wrap="square" lIns="0" tIns="0" rIns="0" bIns="0" rtlCol="0" anchor="t"/>
           <a:lstStyle/>
           <a:p>
             <a:pPr indent="0" marL="0">
@@ -1834,7 +1839,7 @@
           <a:ln/>
         </p:spPr>
         <p:txBody>
-          <a:bodyPr wrap="square" lIns="0" tIns="0" rIns="0" bIns="0" rtlCol="0" anchor="ctr"/>
+          <a:bodyPr wrap="square" lIns="0" tIns="0" rIns="0" bIns="0" rtlCol="0" anchor="t"/>
           <a:lstStyle/>
           <a:p>
             <a:pPr indent="0" marL="0">
@@ -2115,7 +2120,7 @@
           <a:ln/>
         </p:spPr>
         <p:txBody>
-          <a:bodyPr wrap="square" lIns="0" tIns="0" rIns="0" bIns="0" rtlCol="0" anchor="ctr"/>
+          <a:bodyPr wrap="square" lIns="0" tIns="0" rIns="0" bIns="0" rtlCol="0" anchor="t"/>
           <a:lstStyle/>
           <a:p>
             <a:pPr indent="0" marL="0">
@@ -2154,7 +2159,7 @@
           <a:ln/>
         </p:spPr>
         <p:txBody>
-          <a:bodyPr wrap="square" lIns="0" tIns="0" rIns="0" bIns="0" rtlCol="0" anchor="ctr"/>
+          <a:bodyPr wrap="square" lIns="0" tIns="0" rIns="0" bIns="0" rtlCol="0" anchor="t"/>
           <a:lstStyle/>
           <a:p>
             <a:pPr indent="0" marL="0">
@@ -2286,7 +2291,7 @@
           <a:ln/>
         </p:spPr>
         <p:txBody>
-          <a:bodyPr wrap="square" lIns="0" tIns="0" rIns="0" bIns="0" rtlCol="0" anchor="ctr"/>
+          <a:bodyPr wrap="square" lIns="0" tIns="0" rIns="0" bIns="0" rtlCol="0" anchor="t"/>
           <a:lstStyle/>
           <a:p>
             <a:pPr indent="0" marL="0">
@@ -2325,7 +2330,7 @@
           <a:ln/>
         </p:spPr>
         <p:txBody>
-          <a:bodyPr wrap="square" lIns="0" tIns="0" rIns="0" bIns="0" rtlCol="0" anchor="ctr"/>
+          <a:bodyPr wrap="square" lIns="0" tIns="0" rIns="0" bIns="0" rtlCol="0" anchor="t"/>
           <a:lstStyle/>
           <a:p>
             <a:pPr indent="0" marL="0">
@@ -2457,7 +2462,7 @@
           <a:ln/>
         </p:spPr>
         <p:txBody>
-          <a:bodyPr wrap="square" lIns="0" tIns="0" rIns="0" bIns="0" rtlCol="0" anchor="ctr"/>
+          <a:bodyPr wrap="square" lIns="0" tIns="0" rIns="0" bIns="0" rtlCol="0" anchor="t"/>
           <a:lstStyle/>
           <a:p>
             <a:pPr indent="0" marL="0">
@@ -2496,7 +2501,7 @@
           <a:ln/>
         </p:spPr>
         <p:txBody>
-          <a:bodyPr wrap="square" lIns="0" tIns="0" rIns="0" bIns="0" rtlCol="0" anchor="ctr"/>
+          <a:bodyPr wrap="square" lIns="0" tIns="0" rIns="0" bIns="0" rtlCol="0" anchor="t"/>
           <a:lstStyle/>
           <a:p>
             <a:pPr indent="0" marL="0">
@@ -2628,7 +2633,7 @@
           <a:ln/>
         </p:spPr>
         <p:txBody>
-          <a:bodyPr wrap="square" lIns="0" tIns="0" rIns="0" bIns="0" rtlCol="0" anchor="ctr"/>
+          <a:bodyPr wrap="square" lIns="0" tIns="0" rIns="0" bIns="0" rtlCol="0" anchor="t"/>
           <a:lstStyle/>
           <a:p>
             <a:pPr indent="0" marL="0">
@@ -2667,7 +2672,7 @@
           <a:ln/>
         </p:spPr>
         <p:txBody>
-          <a:bodyPr wrap="square" lIns="0" tIns="0" rIns="0" bIns="0" rtlCol="0" anchor="ctr"/>
+          <a:bodyPr wrap="square" lIns="0" tIns="0" rIns="0" bIns="0" rtlCol="0" anchor="t"/>
           <a:lstStyle/>
           <a:p>
             <a:pPr indent="0" marL="0">
@@ -2799,7 +2804,7 @@
           <a:ln/>
         </p:spPr>
         <p:txBody>
-          <a:bodyPr wrap="square" lIns="0" tIns="0" rIns="0" bIns="0" rtlCol="0" anchor="ctr"/>
+          <a:bodyPr wrap="square" lIns="0" tIns="0" rIns="0" bIns="0" rtlCol="0" anchor="t"/>
           <a:lstStyle/>
           <a:p>
             <a:pPr indent="0" marL="0">
@@ -2838,7 +2843,7 @@
           <a:ln/>
         </p:spPr>
         <p:txBody>
-          <a:bodyPr wrap="square" lIns="0" tIns="0" rIns="0" bIns="0" rtlCol="0" anchor="ctr"/>
+          <a:bodyPr wrap="square" lIns="0" tIns="0" rIns="0" bIns="0" rtlCol="0" anchor="t"/>
           <a:lstStyle/>
           <a:p>
             <a:pPr indent="0" marL="0">
@@ -2877,7 +2882,7 @@
           <a:ln/>
         </p:spPr>
         <p:txBody>
-          <a:bodyPr wrap="square" lIns="0" tIns="0" rIns="0" bIns="0" rtlCol="0" anchor="ctr"/>
+          <a:bodyPr wrap="square" lIns="0" tIns="0" rIns="0" bIns="0" rtlCol="0" anchor="t"/>
           <a:lstStyle/>
           <a:p>
             <a:pPr indent="0" marL="0">
@@ -2941,7 +2946,7 @@
           <a:ln/>
         </p:spPr>
         <p:txBody>
-          <a:bodyPr wrap="square" lIns="0" tIns="0" rIns="0" bIns="0" rtlCol="0" anchor="ctr"/>
+          <a:bodyPr wrap="square" lIns="0" tIns="0" rIns="0" bIns="0" rtlCol="0" anchor="t"/>
           <a:lstStyle/>
           <a:p>
             <a:pPr indent="0" marL="0">
@@ -2980,7 +2985,7 @@
           <a:ln/>
         </p:spPr>
         <p:txBody>
-          <a:bodyPr wrap="square" lIns="0" tIns="0" rIns="0" bIns="0" rtlCol="0" anchor="ctr"/>
+          <a:bodyPr wrap="square" lIns="0" tIns="0" rIns="0" bIns="0" rtlCol="0" anchor="t"/>
           <a:lstStyle/>
           <a:p>
             <a:pPr indent="0" marL="0">
@@ -3046,7 +3051,7 @@
           <a:ln/>
         </p:spPr>
         <p:txBody>
-          <a:bodyPr wrap="square" lIns="0" tIns="0" rIns="0" bIns="0" rtlCol="0" anchor="ctr"/>
+          <a:bodyPr wrap="square" lIns="0" tIns="0" rIns="0" bIns="0" rtlCol="0" anchor="t"/>
           <a:lstStyle/>
           <a:p>
             <a:pPr indent="0" marL="0">
@@ -3112,7 +3117,7 @@
           <a:ln/>
         </p:spPr>
         <p:txBody>
-          <a:bodyPr wrap="square" lIns="0" tIns="0" rIns="0" bIns="0" rtlCol="0" anchor="ctr"/>
+          <a:bodyPr wrap="square" lIns="0" tIns="0" rIns="0" bIns="0" rtlCol="0" anchor="t"/>
           <a:lstStyle/>
           <a:p>
             <a:pPr indent="0" marL="0">
@@ -3151,7 +3156,7 @@
           <a:ln/>
         </p:spPr>
         <p:txBody>
-          <a:bodyPr wrap="square" lIns="0" tIns="0" rIns="0" bIns="0" rtlCol="0" anchor="ctr"/>
+          <a:bodyPr wrap="square" lIns="0" tIns="0" rIns="0" bIns="0" rtlCol="0" anchor="t"/>
           <a:lstStyle/>
           <a:p>
             <a:pPr indent="0" marL="0">
@@ -3217,7 +3222,7 @@
           <a:ln/>
         </p:spPr>
         <p:txBody>
-          <a:bodyPr wrap="square" lIns="0" tIns="0" rIns="0" bIns="0" rtlCol="0" anchor="ctr"/>
+          <a:bodyPr wrap="square" lIns="0" tIns="0" rIns="0" bIns="0" rtlCol="0" anchor="t"/>
           <a:lstStyle/>
           <a:p>
             <a:pPr indent="0" marL="0">
@@ -3256,7 +3261,7 @@
           <a:ln/>
         </p:spPr>
         <p:txBody>
-          <a:bodyPr wrap="square" lIns="0" tIns="0" rIns="0" bIns="0" rtlCol="0" anchor="ctr"/>
+          <a:bodyPr wrap="square" lIns="0" tIns="0" rIns="0" bIns="0" rtlCol="0" anchor="t"/>
           <a:lstStyle/>
           <a:p>
             <a:pPr indent="0" marL="0">
@@ -3322,7 +3327,7 @@
           <a:ln/>
         </p:spPr>
         <p:txBody>
-          <a:bodyPr wrap="square" lIns="0" tIns="0" rIns="0" bIns="0" rtlCol="0" anchor="ctr"/>
+          <a:bodyPr wrap="square" lIns="0" tIns="0" rIns="0" bIns="0" rtlCol="0" anchor="t"/>
           <a:lstStyle/>
           <a:p>
             <a:pPr indent="0" marL="0">
@@ -3361,7 +3366,7 @@
           <a:ln/>
         </p:spPr>
         <p:txBody>
-          <a:bodyPr wrap="square" lIns="0" tIns="0" rIns="0" bIns="0" rtlCol="0" anchor="ctr"/>
+          <a:bodyPr wrap="square" lIns="0" tIns="0" rIns="0" bIns="0" rtlCol="0" anchor="t"/>
           <a:lstStyle/>
           <a:p>
             <a:pPr indent="0" marL="0">
@@ -3427,7 +3432,7 @@
           <a:ln/>
         </p:spPr>
         <p:txBody>
-          <a:bodyPr wrap="square" lIns="0" tIns="0" rIns="0" bIns="0" rtlCol="0" anchor="ctr"/>
+          <a:bodyPr wrap="square" lIns="0" tIns="0" rIns="0" bIns="0" rtlCol="0" anchor="t"/>
           <a:lstStyle/>
           <a:p>
             <a:pPr algn="ctr" indent="0" marL="0">
@@ -3466,7 +3471,7 @@
           <a:ln/>
         </p:spPr>
         <p:txBody>
-          <a:bodyPr wrap="square" lIns="0" tIns="0" rIns="0" bIns="0" rtlCol="0" anchor="ctr"/>
+          <a:bodyPr wrap="square" lIns="0" tIns="0" rIns="0" bIns="0" rtlCol="0" anchor="t"/>
           <a:lstStyle/>
           <a:p>
             <a:pPr algn="ctr" indent="0" marL="0">
@@ -3681,7 +3686,7 @@
           <a:ln/>
         </p:spPr>
         <p:txBody>
-          <a:bodyPr wrap="square" lIns="0" tIns="0" rIns="0" bIns="0" rtlCol="0" anchor="ctr"/>
+          <a:bodyPr wrap="square" lIns="0" tIns="0" rIns="0" bIns="0" rtlCol="0" anchor="t"/>
           <a:lstStyle/>
           <a:p>
             <a:pPr algn="ctr" indent="0" marL="0">
@@ -3720,7 +3725,7 @@
           <a:ln/>
         </p:spPr>
         <p:txBody>
-          <a:bodyPr wrap="square" lIns="0" tIns="0" rIns="0" bIns="0" rtlCol="0" anchor="ctr"/>
+          <a:bodyPr wrap="square" lIns="0" tIns="0" rIns="0" bIns="0" rtlCol="0" anchor="t"/>
           <a:lstStyle/>
           <a:p>
             <a:pPr algn="ctr" indent="0" marL="0">
@@ -3759,7 +3764,7 @@
           <a:ln/>
         </p:spPr>
         <p:txBody>
-          <a:bodyPr wrap="square" lIns="0" tIns="0" rIns="0" bIns="0" rtlCol="0" anchor="ctr"/>
+          <a:bodyPr wrap="square" lIns="0" tIns="0" rIns="0" bIns="0" rtlCol="0" anchor="t"/>
           <a:lstStyle/>
           <a:p>
             <a:pPr algn="ctr" indent="0" marL="0">
@@ -3882,7 +3887,7 @@
           <a:ln/>
         </p:spPr>
         <p:txBody>
-          <a:bodyPr wrap="square" lIns="0" tIns="0" rIns="0" bIns="0" rtlCol="0" anchor="ctr"/>
+          <a:bodyPr wrap="square" lIns="0" tIns="0" rIns="0" bIns="0" rtlCol="0" anchor="t"/>
           <a:lstStyle/>
           <a:p>
             <a:pPr algn="ctr" indent="0" marL="0">
@@ -3921,7 +3926,7 @@
           <a:ln/>
         </p:spPr>
         <p:txBody>
-          <a:bodyPr wrap="square" lIns="0" tIns="0" rIns="0" bIns="0" rtlCol="0" anchor="ctr"/>
+          <a:bodyPr wrap="square" lIns="0" tIns="0" rIns="0" bIns="0" rtlCol="0" anchor="t"/>
           <a:lstStyle/>
           <a:p>
             <a:pPr algn="ctr" indent="0" marL="0">
@@ -3960,7 +3965,7 @@
           <a:ln/>
         </p:spPr>
         <p:txBody>
-          <a:bodyPr wrap="square" lIns="0" tIns="0" rIns="0" bIns="0" rtlCol="0" anchor="ctr"/>
+          <a:bodyPr wrap="square" lIns="0" tIns="0" rIns="0" bIns="0" rtlCol="0" anchor="t"/>
           <a:lstStyle/>
           <a:p>
             <a:pPr indent="0" marL="0">
@@ -3999,7 +4004,7 @@
           <a:ln/>
         </p:spPr>
         <p:txBody>
-          <a:bodyPr wrap="square" lIns="0" tIns="0" rIns="0" bIns="0" rtlCol="0" anchor="ctr"/>
+          <a:bodyPr wrap="square" lIns="0" tIns="0" rIns="0" bIns="0" rtlCol="0" anchor="t"/>
           <a:lstStyle/>
           <a:p>
             <a:pPr indent="0" marL="0">
@@ -4063,7 +4068,7 @@
           <a:ln/>
         </p:spPr>
         <p:txBody>
-          <a:bodyPr wrap="square" lIns="0" tIns="0" rIns="0" bIns="0" rtlCol="0" anchor="ctr"/>
+          <a:bodyPr wrap="square" lIns="0" tIns="0" rIns="0" bIns="0" rtlCol="0" anchor="t"/>
           <a:lstStyle/>
           <a:p>
             <a:pPr indent="0" marL="0">
@@ -4102,7 +4107,7 @@
           <a:ln/>
         </p:spPr>
         <p:txBody>
-          <a:bodyPr wrap="square" lIns="0" tIns="0" rIns="0" bIns="0" rtlCol="0" anchor="ctr"/>
+          <a:bodyPr wrap="square" lIns="0" tIns="0" rIns="0" bIns="0" rtlCol="0" anchor="t"/>
           <a:lstStyle/>
           <a:p>
             <a:pPr indent="0" marL="0">
@@ -4125,18 +4130,57 @@
       </p:sp>
       <p:sp>
         <p:nvSpPr>
-          <p:cNvPr id="4" name="Shape 2"/>
+          <p:cNvPr id="4" name="Text 2"/>
+          <p:cNvSpPr txBox="1"/>
+          <p:nvPr/>
+        </p:nvSpPr>
+        <p:spPr>
+          <a:xfrm>
+            <a:off x="640080" y="1316736"/>
+            <a:ext cx="10911535" cy="274320"/>
+          </a:xfrm>
+          <a:prstGeom prst="rect">
+            <a:avLst/>
+          </a:prstGeom>
+          <a:noFill/>
+          <a:ln/>
+        </p:spPr>
+        <p:txBody>
+          <a:bodyPr wrap="square" lIns="0" tIns="0" rIns="0" bIns="0" rtlCol="0" anchor="t"/>
+          <a:lstStyle/>
+          <a:p>
+            <a:pPr indent="0" marL="0">
+              <a:buNone/>
+            </a:pPr>
+            <a:r>
+              <a:rPr lang="en-US" sz="1250" dirty="0">
+                <a:solidFill>
+                  <a:srgbClr val="6B7784"/>
+                </a:solidFill>
+                <a:latin typeface="Calibri" pitchFamily="34" charset="0"/>
+                <a:ea typeface="Calibri" pitchFamily="34" charset="-122"/>
+                <a:cs typeface="Calibri" pitchFamily="34" charset="-120"/>
+              </a:rPr>
+              <a:t>Two absolute URLs, entered separately — nothing is appended to a base URL, and no path is imposed.</a:t>
+            </a:r>
+            <a:endParaRPr lang="en-US" sz="1250" dirty="0"/>
+          </a:p>
+        </p:txBody>
+      </p:sp>
+      <p:sp>
+        <p:nvSpPr>
+          <p:cNvPr id="5" name="Shape 3"/>
           <p:cNvSpPr/>
           <p:nvPr/>
         </p:nvSpPr>
         <p:spPr>
           <a:xfrm>
-            <a:off x="640080" y="1600200"/>
-            <a:ext cx="5285232" cy="3200400"/>
+            <a:off x="640080" y="1664208"/>
+            <a:ext cx="5285232" cy="2880360"/>
           </a:xfrm>
           <a:prstGeom prst="roundRect">
             <a:avLst>
-              <a:gd name="adj" fmla="val 2286"/>
+              <a:gd name="adj" fmla="val 2540"/>
             </a:avLst>
           </a:prstGeom>
           <a:solidFill>
@@ -4152,13 +4196,13 @@
       </p:sp>
       <p:sp>
         <p:nvSpPr>
-          <p:cNvPr id="5" name="Text 3"/>
-          <p:cNvSpPr txBox="1"/>
-          <p:nvPr/>
-        </p:nvSpPr>
-        <p:spPr>
-          <a:xfrm>
-            <a:off x="932688" y="1828800"/>
+          <p:cNvPr id="6" name="Text 4"/>
+          <p:cNvSpPr txBox="1"/>
+          <p:nvPr/>
+        </p:nvSpPr>
+        <p:spPr>
+          <a:xfrm>
+            <a:off x="932688" y="1874520"/>
             <a:ext cx="4700016" cy="329184"/>
           </a:xfrm>
           <a:prstGeom prst="rect">
@@ -4168,7 +4212,7 @@
           <a:ln/>
         </p:spPr>
         <p:txBody>
-          <a:bodyPr wrap="square" lIns="0" tIns="0" rIns="0" bIns="0" rtlCol="0" anchor="ctr"/>
+          <a:bodyPr wrap="square" lIns="0" tIns="0" rIns="0" bIns="0" rtlCol="0" anchor="t"/>
           <a:lstStyle/>
           <a:p>
             <a:pPr indent="0" marL="0">
@@ -4191,13 +4235,13 @@
       </p:sp>
       <p:sp>
         <p:nvSpPr>
-          <p:cNvPr id="6" name="Text 4"/>
-          <p:cNvSpPr txBox="1"/>
-          <p:nvPr/>
-        </p:nvSpPr>
-        <p:spPr>
-          <a:xfrm>
-            <a:off x="932688" y="2212848"/>
+          <p:cNvPr id="7" name="Text 5"/>
+          <p:cNvSpPr txBox="1"/>
+          <p:nvPr/>
+        </p:nvSpPr>
+        <p:spPr>
+          <a:xfrm>
+            <a:off x="932688" y="2240280"/>
             <a:ext cx="4700016" cy="292608"/>
           </a:xfrm>
           <a:prstGeom prst="rect">
@@ -4207,7 +4251,7 @@
           <a:ln/>
         </p:spPr>
         <p:txBody>
-          <a:bodyPr wrap="square" lIns="0" tIns="0" rIns="0" bIns="0" rtlCol="0" anchor="ctr"/>
+          <a:bodyPr wrap="square" lIns="0" tIns="0" rIns="0" bIns="0" rtlCol="0" anchor="t"/>
           <a:lstStyle/>
           <a:p>
             <a:pPr indent="0" marL="0">
@@ -4230,14 +4274,14 @@
       </p:sp>
       <p:sp>
         <p:nvSpPr>
-          <p:cNvPr id="7" name="Text 5"/>
+          <p:cNvPr id="8" name="Text 6"/>
           <p:cNvSpPr txBox="1"/>
           <p:nvPr/>
         </p:nvSpPr>
         <p:spPr>
           <a:xfrm>
             <a:off x="932688" y="2697480"/>
-            <a:ext cx="4700016" cy="2194560"/>
+            <a:ext cx="4700016" cy="1737360"/>
           </a:xfrm>
           <a:prstGeom prst="rect">
             <a:avLst/>
@@ -4251,7 +4295,7 @@
           <a:p>
             <a:pPr marL="342900" indent="-342900">
               <a:spcAft>
-                <a:spcPts val="900"/>
+                <a:spcPts val="800"/>
               </a:spcAft>
               <a:buSzPct val="100000"/>
               <a:buChar char="•"/>
@@ -4272,7 +4316,7 @@
           <a:p>
             <a:pPr marL="342900" indent="-342900">
               <a:spcAft>
-                <a:spcPts val="900"/>
+                <a:spcPts val="800"/>
               </a:spcAft>
               <a:buSzPct val="100000"/>
               <a:buChar char="•"/>
@@ -4293,7 +4337,7 @@
           <a:p>
             <a:pPr marL="342900" indent="-342900">
               <a:spcAft>
-                <a:spcPts val="900"/>
+                <a:spcPts val="800"/>
               </a:spcAft>
               <a:buSzPct val="100000"/>
               <a:buChar char="•"/>
@@ -4314,7 +4358,7 @@
           <a:p>
             <a:pPr marL="342900" indent="-342900">
               <a:spcAft>
-                <a:spcPts val="900"/>
+                <a:spcPts val="800"/>
               </a:spcAft>
               <a:buSzPct val="100000"/>
               <a:buChar char="•"/>
@@ -4336,18 +4380,18 @@
       </p:sp>
       <p:sp>
         <p:nvSpPr>
-          <p:cNvPr id="8" name="Shape 6"/>
+          <p:cNvPr id="9" name="Shape 7"/>
           <p:cNvSpPr/>
           <p:nvPr/>
         </p:nvSpPr>
         <p:spPr>
           <a:xfrm>
-            <a:off x="6272784" y="1600200"/>
-            <a:ext cx="5285232" cy="3200400"/>
+            <a:off x="6272784" y="1664208"/>
+            <a:ext cx="5285232" cy="2880360"/>
           </a:xfrm>
           <a:prstGeom prst="roundRect">
             <a:avLst>
-              <a:gd name="adj" fmla="val 2286"/>
+              <a:gd name="adj" fmla="val 2540"/>
             </a:avLst>
           </a:prstGeom>
           <a:solidFill>
@@ -4363,13 +4407,13 @@
       </p:sp>
       <p:sp>
         <p:nvSpPr>
-          <p:cNvPr id="9" name="Text 7"/>
-          <p:cNvSpPr txBox="1"/>
-          <p:nvPr/>
-        </p:nvSpPr>
-        <p:spPr>
-          <a:xfrm>
-            <a:off x="6565392" y="1828800"/>
+          <p:cNvPr id="10" name="Text 8"/>
+          <p:cNvSpPr txBox="1"/>
+          <p:nvPr/>
+        </p:nvSpPr>
+        <p:spPr>
+          <a:xfrm>
+            <a:off x="6565392" y="1874520"/>
             <a:ext cx="4700016" cy="329184"/>
           </a:xfrm>
           <a:prstGeom prst="rect">
@@ -4379,7 +4423,7 @@
           <a:ln/>
         </p:spPr>
         <p:txBody>
-          <a:bodyPr wrap="square" lIns="0" tIns="0" rIns="0" bIns="0" rtlCol="0" anchor="ctr"/>
+          <a:bodyPr wrap="square" lIns="0" tIns="0" rIns="0" bIns="0" rtlCol="0" anchor="t"/>
           <a:lstStyle/>
           <a:p>
             <a:pPr indent="0" marL="0">
@@ -4402,13 +4446,13 @@
       </p:sp>
       <p:sp>
         <p:nvSpPr>
-          <p:cNvPr id="10" name="Text 8"/>
-          <p:cNvSpPr txBox="1"/>
-          <p:nvPr/>
-        </p:nvSpPr>
-        <p:spPr>
-          <a:xfrm>
-            <a:off x="6565392" y="2212848"/>
+          <p:cNvPr id="11" name="Text 9"/>
+          <p:cNvSpPr txBox="1"/>
+          <p:nvPr/>
+        </p:nvSpPr>
+        <p:spPr>
+          <a:xfrm>
+            <a:off x="6565392" y="2240280"/>
             <a:ext cx="4700016" cy="292608"/>
           </a:xfrm>
           <a:prstGeom prst="rect">
@@ -4418,7 +4462,7 @@
           <a:ln/>
         </p:spPr>
         <p:txBody>
-          <a:bodyPr wrap="square" lIns="0" tIns="0" rIns="0" bIns="0" rtlCol="0" anchor="ctr"/>
+          <a:bodyPr wrap="square" lIns="0" tIns="0" rIns="0" bIns="0" rtlCol="0" anchor="t"/>
           <a:lstStyle/>
           <a:p>
             <a:pPr indent="0" marL="0">
@@ -4441,14 +4485,14 @@
       </p:sp>
       <p:sp>
         <p:nvSpPr>
-          <p:cNvPr id="11" name="Text 9"/>
+          <p:cNvPr id="12" name="Text 10"/>
           <p:cNvSpPr txBox="1"/>
           <p:nvPr/>
         </p:nvSpPr>
         <p:spPr>
           <a:xfrm>
             <a:off x="6565392" y="2697480"/>
-            <a:ext cx="4700016" cy="2194560"/>
+            <a:ext cx="4700016" cy="1737360"/>
           </a:xfrm>
           <a:prstGeom prst="rect">
             <a:avLst/>
@@ -4462,7 +4506,7 @@
           <a:p>
             <a:pPr marL="342900" indent="-342900">
               <a:spcAft>
-                <a:spcPts val="900"/>
+                <a:spcPts val="800"/>
               </a:spcAft>
               <a:buSzPct val="100000"/>
               <a:buChar char="•"/>
@@ -4483,7 +4527,7 @@
           <a:p>
             <a:pPr marL="342900" indent="-342900">
               <a:spcAft>
-                <a:spcPts val="900"/>
+                <a:spcPts val="800"/>
               </a:spcAft>
               <a:buSzPct val="100000"/>
               <a:buChar char="•"/>
@@ -4504,7 +4548,7 @@
           <a:p>
             <a:pPr marL="342900" indent="-342900">
               <a:spcAft>
-                <a:spcPts val="900"/>
+                <a:spcPts val="800"/>
               </a:spcAft>
               <a:buSzPct val="100000"/>
               <a:buChar char="•"/>
@@ -4525,7 +4569,7 @@
           <a:p>
             <a:pPr marL="342900" indent="-342900">
               <a:spcAft>
-                <a:spcPts val="900"/>
+                <a:spcPts val="800"/>
               </a:spcAft>
               <a:buSzPct val="100000"/>
               <a:buChar char="•"/>
@@ -4547,18 +4591,18 @@
       </p:sp>
       <p:sp>
         <p:nvSpPr>
-          <p:cNvPr id="12" name="Shape 10"/>
+          <p:cNvPr id="13" name="Shape 11"/>
           <p:cNvSpPr/>
           <p:nvPr/>
         </p:nvSpPr>
         <p:spPr>
           <a:xfrm>
-            <a:off x="640080" y="4983480"/>
-            <a:ext cx="10911535" cy="1005840"/>
+            <a:off x="640080" y="4800600"/>
+            <a:ext cx="10911535" cy="1600200"/>
           </a:xfrm>
           <a:prstGeom prst="roundRect">
             <a:avLst>
-              <a:gd name="adj" fmla="val 7273"/>
+              <a:gd name="adj" fmla="val 4571"/>
             </a:avLst>
           </a:prstGeom>
           <a:solidFill>
@@ -4574,69 +4618,122 @@
       </p:sp>
       <p:sp>
         <p:nvSpPr>
-          <p:cNvPr id="13" name="Text 11"/>
-          <p:cNvSpPr txBox="1"/>
-          <p:nvPr/>
-        </p:nvSpPr>
-        <p:spPr>
-          <a:xfrm>
-            <a:off x="914400" y="5120640"/>
-            <a:ext cx="10362895" cy="256032"/>
-          </a:xfrm>
-          <a:prstGeom prst="rect">
-            <a:avLst/>
-          </a:prstGeom>
-          <a:noFill/>
-          <a:ln/>
-        </p:spPr>
-        <p:txBody>
-          <a:bodyPr wrap="square" lIns="0" tIns="0" rIns="0" bIns="0" rtlCol="0" anchor="ctr"/>
-          <a:lstStyle/>
-          <a:p>
-            <a:pPr indent="0" marL="0">
-              <a:buNone/>
-            </a:pPr>
-            <a:r>
-              <a:rPr lang="en-US" sz="1300" b="1" dirty="0">
+          <p:cNvPr id="14" name="Text 12"/>
+          <p:cNvSpPr txBox="1"/>
+          <p:nvPr/>
+        </p:nvSpPr>
+        <p:spPr>
+          <a:xfrm>
+            <a:off x="914400" y="4956048"/>
+            <a:ext cx="10362895" cy="274320"/>
+          </a:xfrm>
+          <a:prstGeom prst="rect">
+            <a:avLst/>
+          </a:prstGeom>
+          <a:noFill/>
+          <a:ln/>
+        </p:spPr>
+        <p:txBody>
+          <a:bodyPr wrap="square" lIns="0" tIns="0" rIns="0" bIns="0" rtlCol="0" anchor="t"/>
+          <a:lstStyle/>
+          <a:p>
+            <a:pPr indent="0" marL="0">
+              <a:buNone/>
+            </a:pPr>
+            <a:r>
+              <a:rPr lang="en-US" sz="1250" b="1" dirty="0">
                 <a:solidFill>
                   <a:srgbClr val="1F2933"/>
+                </a:solidFill>
+                <a:latin typeface="Calibri" pitchFamily="34" charset="0"/>
+                <a:ea typeface="Calibri" pitchFamily="34" charset="-122"/>
+                <a:cs typeface="Calibri" pitchFamily="34" charset="-120"/>
+              </a:rPr>
+              <a:t>Authentication unlocks no feature — </a:t>
+            </a:r>
+            <a:pPr indent="0" marL="0">
+              <a:buNone/>
+            </a:pPr>
+            <a:r>
+              <a:rPr lang="en-US" sz="1250" dirty="0">
+                <a:solidFill>
+                  <a:srgbClr val="3A4750"/>
+                </a:solidFill>
+                <a:latin typeface="Calibri" pitchFamily="34" charset="0"/>
+                <a:ea typeface="Calibri" pitchFamily="34" charset="-122"/>
+                <a:cs typeface="Calibri" pitchFamily="34" charset="-120"/>
+              </a:rPr>
+              <a:t>but the platform can send a credential, in either of two shapes.</a:t>
+            </a:r>
+            <a:endParaRPr lang="en-US" sz="1250" dirty="0"/>
+          </a:p>
+        </p:txBody>
+      </p:sp>
+      <p:sp>
+        <p:nvSpPr>
+          <p:cNvPr id="15" name="Text 13"/>
+          <p:cNvSpPr txBox="1"/>
+          <p:nvPr/>
+        </p:nvSpPr>
+        <p:spPr>
+          <a:xfrm>
+            <a:off x="914400" y="5285232"/>
+            <a:ext cx="4992624" cy="237744"/>
+          </a:xfrm>
+          <a:prstGeom prst="rect">
+            <a:avLst/>
+          </a:prstGeom>
+          <a:noFill/>
+          <a:ln/>
+        </p:spPr>
+        <p:txBody>
+          <a:bodyPr wrap="square" lIns="0" tIns="0" rIns="0" bIns="0" rtlCol="0" anchor="t"/>
+          <a:lstStyle/>
+          <a:p>
+            <a:pPr indent="0" marL="0">
+              <a:buNone/>
+            </a:pPr>
+            <a:r>
+              <a:rPr lang="en-US" sz="1250" b="1" dirty="0">
+                <a:solidFill>
+                  <a:srgbClr val="01606B"/>
                 </a:solidFill>
                 <a:latin typeface="Arial" pitchFamily="34" charset="0"/>
                 <a:ea typeface="Arial" pitchFamily="34" charset="-122"/>
                 <a:cs typeface="Arial" pitchFamily="34" charset="-120"/>
               </a:rPr>
-              <a:t>Authentication unlocks nothing</a:t>
-            </a:r>
-            <a:endParaRPr lang="en-US" sz="1300" dirty="0"/>
-          </a:p>
-        </p:txBody>
-      </p:sp>
-      <p:sp>
-        <p:nvSpPr>
-          <p:cNvPr id="14" name="Text 12"/>
-          <p:cNvSpPr txBox="1"/>
-          <p:nvPr/>
-        </p:nvSpPr>
-        <p:spPr>
-          <a:xfrm>
-            <a:off x="914400" y="5413248"/>
-            <a:ext cx="10362895" cy="457200"/>
-          </a:xfrm>
-          <a:prstGeom prst="rect">
-            <a:avLst/>
-          </a:prstGeom>
-          <a:noFill/>
-          <a:ln/>
-        </p:spPr>
-        <p:txBody>
-          <a:bodyPr wrap="square" lIns="0" tIns="0" rIns="0" bIns="0" rtlCol="0" anchor="ctr"/>
-          <a:lstStyle/>
-          <a:p>
-            <a:pPr indent="0" marL="0">
-              <a:buNone/>
-            </a:pPr>
-            <a:r>
-              <a:rPr lang="en-US" sz="1150" dirty="0">
+              <a:t>A key somebody typed</a:t>
+            </a:r>
+            <a:endParaRPr lang="en-US" sz="1250" dirty="0"/>
+          </a:p>
+        </p:txBody>
+      </p:sp>
+      <p:sp>
+        <p:nvSpPr>
+          <p:cNvPr id="16" name="Text 14"/>
+          <p:cNvSpPr txBox="1"/>
+          <p:nvPr/>
+        </p:nvSpPr>
+        <p:spPr>
+          <a:xfrm>
+            <a:off x="914400" y="5541264"/>
+            <a:ext cx="4992624" cy="822960"/>
+          </a:xfrm>
+          <a:prstGeom prst="rect">
+            <a:avLst/>
+          </a:prstGeom>
+          <a:noFill/>
+          <a:ln/>
+        </p:spPr>
+        <p:txBody>
+          <a:bodyPr wrap="square" lIns="0" tIns="0" rIns="0" bIns="0" rtlCol="0" anchor="t"/>
+          <a:lstStyle/>
+          <a:p>
+            <a:pPr indent="0" marL="0">
+              <a:buNone/>
+            </a:pPr>
+            <a:r>
+              <a:rPr lang="en-US" sz="1100" dirty="0">
                 <a:solidFill>
                   <a:srgbClr val="3A4750"/>
                 </a:solidFill>
@@ -4644,46 +4741,85 @@
                 <a:ea typeface="Calibri" pitchFamily="34" charset="-122"/>
                 <a:cs typeface="Calibri" pitchFamily="34" charset="-120"/>
               </a:rPr>
-              <a:t>A server that demands a credential and one that demands none are equally usable here. If yours sits behind a gateway, a developer types the key beside the URL and every request carries it — as a Bearer header, or as a header you name. With no key entered, the request is byte for byte what it was before.</a:t>
-            </a:r>
-            <a:endParaRPr lang="en-US" sz="1150" dirty="0"/>
-          </a:p>
-        </p:txBody>
-      </p:sp>
-      <p:sp>
-        <p:nvSpPr>
-          <p:cNvPr id="15" name="Text 13"/>
-          <p:cNvSpPr txBox="1"/>
-          <p:nvPr/>
-        </p:nvSpPr>
-        <p:spPr>
-          <a:xfrm>
-            <a:off x="640080" y="6236208"/>
-            <a:ext cx="10911535" cy="292608"/>
-          </a:xfrm>
-          <a:prstGeom prst="rect">
-            <a:avLst/>
-          </a:prstGeom>
-          <a:noFill/>
-          <a:ln/>
-        </p:spPr>
-        <p:txBody>
-          <a:bodyPr wrap="square" lIns="0" tIns="0" rIns="0" bIns="0" rtlCol="0" anchor="ctr"/>
-          <a:lstStyle/>
-          <a:p>
-            <a:pPr indent="0" marL="0">
-              <a:buNone/>
-            </a:pPr>
-            <a:r>
-              <a:rPr lang="en-US" sz="1100" i="1" dirty="0">
-                <a:solidFill>
-                  <a:srgbClr val="6B7784"/>
+              <a:t>A developer enters an API key beside the URL, and every request then carries Authorization: Bearer &lt;key&gt; — or a header you name, such as X-Api-Key. With no key entered, no such header is sent at all.</a:t>
+            </a:r>
+            <a:endParaRPr lang="en-US" sz="1100" dirty="0"/>
+          </a:p>
+        </p:txBody>
+      </p:sp>
+      <p:sp>
+        <p:nvSpPr>
+          <p:cNvPr id="17" name="Text 15"/>
+          <p:cNvSpPr txBox="1"/>
+          <p:nvPr/>
+        </p:nvSpPr>
+        <p:spPr>
+          <a:xfrm>
+            <a:off x="6281928" y="5285232"/>
+            <a:ext cx="4992624" cy="237744"/>
+          </a:xfrm>
+          <a:prstGeom prst="rect">
+            <a:avLst/>
+          </a:prstGeom>
+          <a:noFill/>
+          <a:ln/>
+        </p:spPr>
+        <p:txBody>
+          <a:bodyPr wrap="square" lIns="0" tIns="0" rIns="0" bIns="0" rtlCol="0" anchor="t"/>
+          <a:lstStyle/>
+          <a:p>
+            <a:pPr indent="0" marL="0">
+              <a:buNone/>
+            </a:pPr>
+            <a:r>
+              <a:rPr lang="en-US" sz="1250" b="1" dirty="0">
+                <a:solidFill>
+                  <a:srgbClr val="01606B"/>
+                </a:solidFill>
+                <a:latin typeface="Arial" pitchFamily="34" charset="0"/>
+                <a:ea typeface="Arial" pitchFamily="34" charset="-122"/>
+                <a:cs typeface="Arial" pitchFamily="34" charset="-120"/>
+              </a:rPr>
+              <a:t>The caller's own SSO token</a:t>
+            </a:r>
+            <a:endParaRPr lang="en-US" sz="1250" dirty="0"/>
+          </a:p>
+        </p:txBody>
+      </p:sp>
+      <p:sp>
+        <p:nvSpPr>
+          <p:cNvPr id="18" name="Text 16"/>
+          <p:cNvSpPr txBox="1"/>
+          <p:nvPr/>
+        </p:nvSpPr>
+        <p:spPr>
+          <a:xfrm>
+            <a:off x="6281928" y="5541264"/>
+            <a:ext cx="4992624" cy="822960"/>
+          </a:xfrm>
+          <a:prstGeom prst="rect">
+            <a:avLst/>
+          </a:prstGeom>
+          <a:noFill/>
+          <a:ln/>
+        </p:spPr>
+        <p:txBody>
+          <a:bodyPr wrap="square" lIns="0" tIns="0" rIns="0" bIns="0" rtlCol="0" anchor="t"/>
+          <a:lstStyle/>
+          <a:p>
+            <a:pPr indent="0" marL="0">
+              <a:buNone/>
+            </a:pPr>
+            <a:r>
+              <a:rPr lang="en-US" sz="1100" dirty="0">
+                <a:solidFill>
+                  <a:srgbClr val="3A4750"/>
                 </a:solidFill>
                 <a:latin typeface="Calibri" pitchFamily="34" charset="0"/>
                 <a:ea typeface="Calibri" pitchFamily="34" charset="-122"/>
                 <a:cs typeface="Calibri" pitchFamily="34" charset="-120"/>
               </a:rPr>
-              <a:t>Two absolute URLs, entered separately. Nothing is appended to a base URL and no path is imposed — different prefixes, gateways, even different hosts are all fine.</a:t>
+              <a:t>The platform can instead authenticate to you as whoever is signed in — the only mode that tells you who is asking, so an agent with its own per-user authorization can apply it. Accept the same realm and audience; tokens are re-minted mid-run, so cache on the claims, not the token text.</a:t>
             </a:r>
             <a:endParaRPr lang="en-US" sz="1100" dirty="0"/>
           </a:p>
@@ -4732,7 +4868,7 @@
           <a:ln/>
         </p:spPr>
         <p:txBody>
-          <a:bodyPr wrap="square" lIns="0" tIns="0" rIns="0" bIns="0" rtlCol="0" anchor="ctr"/>
+          <a:bodyPr wrap="square" lIns="0" tIns="0" rIns="0" bIns="0" rtlCol="0" anchor="t"/>
           <a:lstStyle/>
           <a:p>
             <a:pPr indent="0" marL="0">
@@ -4771,7 +4907,7 @@
           <a:ln/>
         </p:spPr>
         <p:txBody>
-          <a:bodyPr wrap="square" lIns="0" tIns="0" rIns="0" bIns="0" rtlCol="0" anchor="ctr"/>
+          <a:bodyPr wrap="square" lIns="0" tIns="0" rIns="0" bIns="0" rtlCol="0" anchor="t"/>
           <a:lstStyle/>
           <a:p>
             <a:pPr indent="0" marL="0">
@@ -6144,7 +6280,7 @@
           <a:ln/>
         </p:spPr>
         <p:txBody>
-          <a:bodyPr wrap="square" lIns="0" tIns="0" rIns="0" bIns="0" rtlCol="0" anchor="ctr"/>
+          <a:bodyPr wrap="square" lIns="0" tIns="0" rIns="0" bIns="0" rtlCol="0" anchor="t"/>
           <a:lstStyle/>
           <a:p>
             <a:pPr indent="0" marL="0">
@@ -6250,7 +6386,7 @@
           <a:ln/>
         </p:spPr>
         <p:txBody>
-          <a:bodyPr wrap="square" lIns="0" tIns="0" rIns="0" bIns="0" rtlCol="0" anchor="ctr"/>
+          <a:bodyPr wrap="square" lIns="0" tIns="0" rIns="0" bIns="0" rtlCol="0" anchor="t"/>
           <a:lstStyle/>
           <a:p>
             <a:pPr indent="0" marL="0">
@@ -6289,7 +6425,7 @@
           <a:ln/>
         </p:spPr>
         <p:txBody>
-          <a:bodyPr wrap="square" lIns="0" tIns="0" rIns="0" bIns="0" rtlCol="0" anchor="ctr"/>
+          <a:bodyPr wrap="square" lIns="0" tIns="0" rIns="0" bIns="0" rtlCol="0" anchor="t"/>
           <a:lstStyle/>
           <a:p>
             <a:pPr indent="0" marL="0">
@@ -6597,7 +6733,7 @@
           <a:ln/>
         </p:spPr>
         <p:txBody>
-          <a:bodyPr wrap="square" lIns="0" tIns="0" rIns="0" bIns="0" rtlCol="0" anchor="ctr"/>
+          <a:bodyPr wrap="square" lIns="0" tIns="0" rIns="0" bIns="0" rtlCol="0" anchor="t"/>
           <a:lstStyle/>
           <a:p>
             <a:pPr indent="0" marL="0">
@@ -6742,7 +6878,7 @@
           <a:ln/>
         </p:spPr>
         <p:txBody>
-          <a:bodyPr wrap="square" lIns="0" tIns="0" rIns="0" bIns="0" rtlCol="0" anchor="ctr"/>
+          <a:bodyPr wrap="square" lIns="0" tIns="0" rIns="0" bIns="0" rtlCol="0" anchor="t"/>
           <a:lstStyle/>
           <a:p>
             <a:pPr indent="0" marL="0">
@@ -6808,7 +6944,7 @@
           <a:ln/>
         </p:spPr>
         <p:txBody>
-          <a:bodyPr wrap="square" lIns="0" tIns="0" rIns="0" bIns="0" rtlCol="0" anchor="ctr"/>
+          <a:bodyPr wrap="square" lIns="0" tIns="0" rIns="0" bIns="0" rtlCol="0" anchor="t"/>
           <a:lstStyle/>
           <a:p>
             <a:pPr indent="0" marL="0">
@@ -6847,7 +6983,7 @@
           <a:ln/>
         </p:spPr>
         <p:txBody>
-          <a:bodyPr wrap="square" lIns="0" tIns="0" rIns="0" bIns="0" rtlCol="0" anchor="ctr"/>
+          <a:bodyPr wrap="square" lIns="0" tIns="0" rIns="0" bIns="0" rtlCol="0" anchor="t"/>
           <a:lstStyle/>
           <a:p>
             <a:pPr indent="0" marL="0">
@@ -6913,7 +7049,7 @@
           <a:ln/>
         </p:spPr>
         <p:txBody>
-          <a:bodyPr wrap="square" lIns="0" tIns="0" rIns="0" bIns="0" rtlCol="0" anchor="ctr"/>
+          <a:bodyPr wrap="square" lIns="0" tIns="0" rIns="0" bIns="0" rtlCol="0" anchor="t"/>
           <a:lstStyle/>
           <a:p>
             <a:pPr indent="0" marL="0">
@@ -6952,7 +7088,7 @@
           <a:ln/>
         </p:spPr>
         <p:txBody>
-          <a:bodyPr wrap="square" lIns="0" tIns="0" rIns="0" bIns="0" rtlCol="0" anchor="ctr"/>
+          <a:bodyPr wrap="square" lIns="0" tIns="0" rIns="0" bIns="0" rtlCol="0" anchor="t"/>
           <a:lstStyle/>
           <a:p>
             <a:pPr indent="0" marL="0">
@@ -7018,7 +7154,7 @@
           <a:ln/>
         </p:spPr>
         <p:txBody>
-          <a:bodyPr wrap="square" lIns="0" tIns="0" rIns="0" bIns="0" rtlCol="0" anchor="ctr"/>
+          <a:bodyPr wrap="square" lIns="0" tIns="0" rIns="0" bIns="0" rtlCol="0" anchor="t"/>
           <a:lstStyle/>
           <a:p>
             <a:pPr indent="0" marL="0">
@@ -7057,7 +7193,7 @@
           <a:ln/>
         </p:spPr>
         <p:txBody>
-          <a:bodyPr wrap="square" lIns="0" tIns="0" rIns="0" bIns="0" rtlCol="0" anchor="ctr"/>
+          <a:bodyPr wrap="square" lIns="0" tIns="0" rIns="0" bIns="0" rtlCol="0" anchor="t"/>
           <a:lstStyle/>
           <a:p>
             <a:pPr indent="0" marL="0">
@@ -7096,7 +7232,7 @@
           <a:ln/>
         </p:spPr>
         <p:txBody>
-          <a:bodyPr wrap="square" lIns="0" tIns="0" rIns="0" bIns="0" rtlCol="0" anchor="ctr"/>
+          <a:bodyPr wrap="square" lIns="0" tIns="0" rIns="0" bIns="0" rtlCol="0" anchor="t"/>
           <a:lstStyle/>
           <a:p>
             <a:pPr indent="0" marL="0">
@@ -7160,7 +7296,7 @@
           <a:ln/>
         </p:spPr>
         <p:txBody>
-          <a:bodyPr wrap="square" lIns="0" tIns="0" rIns="0" bIns="0" rtlCol="0" anchor="ctr"/>
+          <a:bodyPr wrap="square" lIns="0" tIns="0" rIns="0" bIns="0" rtlCol="0" anchor="t"/>
           <a:lstStyle/>
           <a:p>
             <a:pPr indent="0" marL="0">
@@ -7199,7 +7335,7 @@
           <a:ln/>
         </p:spPr>
         <p:txBody>
-          <a:bodyPr wrap="square" lIns="0" tIns="0" rIns="0" bIns="0" rtlCol="0" anchor="ctr"/>
+          <a:bodyPr wrap="square" lIns="0" tIns="0" rIns="0" bIns="0" rtlCol="0" anchor="t"/>
           <a:lstStyle/>
           <a:p>
             <a:pPr indent="0" marL="0">
@@ -7238,7 +7374,7 @@
           <a:ln/>
         </p:spPr>
         <p:txBody>
-          <a:bodyPr wrap="square" lIns="0" tIns="0" rIns="0" bIns="0" rtlCol="0" anchor="ctr"/>
+          <a:bodyPr wrap="square" lIns="0" tIns="0" rIns="0" bIns="0" rtlCol="0" anchor="t"/>
           <a:lstStyle/>
           <a:p>
             <a:pPr indent="0" marL="0">
@@ -7370,7 +7506,7 @@
           <a:ln/>
         </p:spPr>
         <p:txBody>
-          <a:bodyPr wrap="square" lIns="0" tIns="0" rIns="0" bIns="0" rtlCol="0" anchor="ctr"/>
+          <a:bodyPr wrap="square" lIns="0" tIns="0" rIns="0" bIns="0" rtlCol="0" anchor="t"/>
           <a:lstStyle/>
           <a:p>
             <a:pPr indent="0" marL="0">
@@ -7426,7 +7562,7 @@
           <a:ln/>
         </p:spPr>
         <p:txBody>
-          <a:bodyPr wrap="square" lIns="0" tIns="0" rIns="0" bIns="0" rtlCol="0" anchor="ctr"/>
+          <a:bodyPr wrap="square" lIns="0" tIns="0" rIns="0" bIns="0" rtlCol="0" anchor="t"/>
           <a:lstStyle/>
           <a:p>
             <a:pPr indent="0" marL="0">
@@ -7465,7 +7601,7 @@
           <a:ln/>
         </p:spPr>
         <p:txBody>
-          <a:bodyPr wrap="square" lIns="0" tIns="0" rIns="0" bIns="0" rtlCol="0" anchor="ctr"/>
+          <a:bodyPr wrap="square" lIns="0" tIns="0" rIns="0" bIns="0" rtlCol="0" anchor="t"/>
           <a:lstStyle/>
           <a:p>
             <a:pPr indent="0" marL="0">
@@ -7504,7 +7640,7 @@
           <a:ln/>
         </p:spPr>
         <p:txBody>
-          <a:bodyPr wrap="square" lIns="0" tIns="0" rIns="0" bIns="0" rtlCol="0" anchor="ctr"/>
+          <a:bodyPr wrap="square" lIns="0" tIns="0" rIns="0" bIns="0" rtlCol="0" anchor="t"/>
           <a:lstStyle/>
           <a:p>
             <a:pPr indent="0" marL="0">
@@ -7543,7 +7679,7 @@
           <a:ln/>
         </p:spPr>
         <p:txBody>
-          <a:bodyPr wrap="square" lIns="0" tIns="0" rIns="0" bIns="0" rtlCol="0" anchor="ctr"/>
+          <a:bodyPr wrap="square" lIns="0" tIns="0" rIns="0" bIns="0" rtlCol="0" anchor="t"/>
           <a:lstStyle/>
           <a:p>
             <a:pPr indent="0" marL="0">
@@ -7675,7 +7811,7 @@
           <a:ln/>
         </p:spPr>
         <p:txBody>
-          <a:bodyPr wrap="square" lIns="0" tIns="0" rIns="0" bIns="0" rtlCol="0" anchor="ctr"/>
+          <a:bodyPr wrap="square" lIns="0" tIns="0" rIns="0" bIns="0" rtlCol="0" anchor="t"/>
           <a:lstStyle/>
           <a:p>
             <a:pPr indent="0" marL="0">
@@ -7731,7 +7867,7 @@
           <a:ln/>
         </p:spPr>
         <p:txBody>
-          <a:bodyPr wrap="square" lIns="0" tIns="0" rIns="0" bIns="0" rtlCol="0" anchor="ctr"/>
+          <a:bodyPr wrap="square" lIns="0" tIns="0" rIns="0" bIns="0" rtlCol="0" anchor="t"/>
           <a:lstStyle/>
           <a:p>
             <a:pPr indent="0" marL="0">
@@ -7770,7 +7906,7 @@
           <a:ln/>
         </p:spPr>
         <p:txBody>
-          <a:bodyPr wrap="square" lIns="0" tIns="0" rIns="0" bIns="0" rtlCol="0" anchor="ctr"/>
+          <a:bodyPr wrap="square" lIns="0" tIns="0" rIns="0" bIns="0" rtlCol="0" anchor="t"/>
           <a:lstStyle/>
           <a:p>
             <a:pPr indent="0" marL="0">
@@ -7809,7 +7945,7 @@
           <a:ln/>
         </p:spPr>
         <p:txBody>
-          <a:bodyPr wrap="square" lIns="0" tIns="0" rIns="0" bIns="0" rtlCol="0" anchor="ctr"/>
+          <a:bodyPr wrap="square" lIns="0" tIns="0" rIns="0" bIns="0" rtlCol="0" anchor="t"/>
           <a:lstStyle/>
           <a:p>
             <a:pPr indent="0" marL="0">
@@ -7848,7 +7984,7 @@
           <a:ln/>
         </p:spPr>
         <p:txBody>
-          <a:bodyPr wrap="square" lIns="0" tIns="0" rIns="0" bIns="0" rtlCol="0" anchor="ctr"/>
+          <a:bodyPr wrap="square" lIns="0" tIns="0" rIns="0" bIns="0" rtlCol="0" anchor="t"/>
           <a:lstStyle/>
           <a:p>
             <a:pPr indent="0" marL="0">
@@ -7980,7 +8116,7 @@
           <a:ln/>
         </p:spPr>
         <p:txBody>
-          <a:bodyPr wrap="square" lIns="0" tIns="0" rIns="0" bIns="0" rtlCol="0" anchor="ctr"/>
+          <a:bodyPr wrap="square" lIns="0" tIns="0" rIns="0" bIns="0" rtlCol="0" anchor="t"/>
           <a:lstStyle/>
           <a:p>
             <a:pPr indent="0" marL="0">
@@ -8036,7 +8172,7 @@
           <a:ln/>
         </p:spPr>
         <p:txBody>
-          <a:bodyPr wrap="square" lIns="0" tIns="0" rIns="0" bIns="0" rtlCol="0" anchor="ctr"/>
+          <a:bodyPr wrap="square" lIns="0" tIns="0" rIns="0" bIns="0" rtlCol="0" anchor="t"/>
           <a:lstStyle/>
           <a:p>
             <a:pPr indent="0" marL="0">
@@ -8075,7 +8211,7 @@
           <a:ln/>
         </p:spPr>
         <p:txBody>
-          <a:bodyPr wrap="square" lIns="0" tIns="0" rIns="0" bIns="0" rtlCol="0" anchor="ctr"/>
+          <a:bodyPr wrap="square" lIns="0" tIns="0" rIns="0" bIns="0" rtlCol="0" anchor="t"/>
           <a:lstStyle/>
           <a:p>
             <a:pPr indent="0" marL="0">
@@ -8114,7 +8250,7 @@
           <a:ln/>
         </p:spPr>
         <p:txBody>
-          <a:bodyPr wrap="square" lIns="0" tIns="0" rIns="0" bIns="0" rtlCol="0" anchor="ctr"/>
+          <a:bodyPr wrap="square" lIns="0" tIns="0" rIns="0" bIns="0" rtlCol="0" anchor="t"/>
           <a:lstStyle/>
           <a:p>
             <a:pPr indent="0" marL="0">
@@ -8153,7 +8289,7 @@
           <a:ln/>
         </p:spPr>
         <p:txBody>
-          <a:bodyPr wrap="square" lIns="0" tIns="0" rIns="0" bIns="0" rtlCol="0" anchor="ctr"/>
+          <a:bodyPr wrap="square" lIns="0" tIns="0" rIns="0" bIns="0" rtlCol="0" anchor="t"/>
           <a:lstStyle/>
           <a:p>
             <a:pPr indent="0" marL="0">
@@ -8192,7 +8328,7 @@
           <a:ln/>
         </p:spPr>
         <p:txBody>
-          <a:bodyPr wrap="square" lIns="0" tIns="0" rIns="0" bIns="0" rtlCol="0" anchor="ctr"/>
+          <a:bodyPr wrap="square" lIns="0" tIns="0" rIns="0" bIns="0" rtlCol="0" anchor="t"/>
           <a:lstStyle/>
           <a:p>
             <a:pPr indent="0" marL="0">
@@ -8256,7 +8392,7 @@
           <a:ln/>
         </p:spPr>
         <p:txBody>
-          <a:bodyPr wrap="square" lIns="0" tIns="0" rIns="0" bIns="0" rtlCol="0" anchor="ctr"/>
+          <a:bodyPr wrap="square" lIns="0" tIns="0" rIns="0" bIns="0" rtlCol="0" anchor="t"/>
           <a:lstStyle/>
           <a:p>
             <a:pPr indent="0" marL="0">
@@ -8295,7 +8431,7 @@
           <a:ln/>
         </p:spPr>
         <p:txBody>
-          <a:bodyPr wrap="square" lIns="0" tIns="0" rIns="0" bIns="0" rtlCol="0" anchor="ctr"/>
+          <a:bodyPr wrap="square" lIns="0" tIns="0" rIns="0" bIns="0" rtlCol="0" anchor="t"/>
           <a:lstStyle/>
           <a:p>
             <a:pPr indent="0" marL="0">
@@ -8334,7 +8470,7 @@
           <a:ln/>
         </p:spPr>
         <p:txBody>
-          <a:bodyPr wrap="square" lIns="0" tIns="0" rIns="0" bIns="0" rtlCol="0" anchor="ctr"/>
+          <a:bodyPr wrap="square" lIns="0" tIns="0" rIns="0" bIns="0" rtlCol="0" anchor="t"/>
           <a:lstStyle/>
           <a:p>
             <a:pPr indent="0" marL="0">
@@ -8439,7 +8575,7 @@
           <a:ln/>
         </p:spPr>
         <p:txBody>
-          <a:bodyPr wrap="square" lIns="0" tIns="0" rIns="0" bIns="0" rtlCol="0" anchor="ctr"/>
+          <a:bodyPr wrap="square" lIns="0" tIns="0" rIns="0" bIns="0" rtlCol="0" anchor="t"/>
           <a:lstStyle/>
           <a:p>
             <a:pPr indent="0" marL="0">
@@ -8478,7 +8614,7 @@
           <a:ln/>
         </p:spPr>
         <p:txBody>
-          <a:bodyPr wrap="square" lIns="0" tIns="0" rIns="0" bIns="0" rtlCol="0" anchor="ctr"/>
+          <a:bodyPr wrap="square" lIns="0" tIns="0" rIns="0" bIns="0" rtlCol="0" anchor="t"/>
           <a:lstStyle/>
           <a:p>
             <a:pPr indent="0" marL="0">
@@ -8583,7 +8719,7 @@
           <a:ln/>
         </p:spPr>
         <p:txBody>
-          <a:bodyPr wrap="square" lIns="0" tIns="0" rIns="0" bIns="0" rtlCol="0" anchor="ctr"/>
+          <a:bodyPr wrap="square" lIns="0" tIns="0" rIns="0" bIns="0" rtlCol="0" anchor="t"/>
           <a:lstStyle/>
           <a:p>
             <a:pPr indent="0" marL="0">
@@ -8622,7 +8758,7 @@
           <a:ln/>
         </p:spPr>
         <p:txBody>
-          <a:bodyPr wrap="square" lIns="0" tIns="0" rIns="0" bIns="0" rtlCol="0" anchor="ctr"/>
+          <a:bodyPr wrap="square" lIns="0" tIns="0" rIns="0" bIns="0" rtlCol="0" anchor="t"/>
           <a:lstStyle/>
           <a:p>
             <a:pPr indent="0" marL="0">
@@ -8727,7 +8863,7 @@
           <a:ln/>
         </p:spPr>
         <p:txBody>
-          <a:bodyPr wrap="square" lIns="0" tIns="0" rIns="0" bIns="0" rtlCol="0" anchor="ctr"/>
+          <a:bodyPr wrap="square" lIns="0" tIns="0" rIns="0" bIns="0" rtlCol="0" anchor="t"/>
           <a:lstStyle/>
           <a:p>
             <a:pPr indent="0" marL="0">
@@ -8766,7 +8902,7 @@
           <a:ln/>
         </p:spPr>
         <p:txBody>
-          <a:bodyPr wrap="square" lIns="0" tIns="0" rIns="0" bIns="0" rtlCol="0" anchor="ctr"/>
+          <a:bodyPr wrap="square" lIns="0" tIns="0" rIns="0" bIns="0" rtlCol="0" anchor="t"/>
           <a:lstStyle/>
           <a:p>
             <a:pPr indent="0" marL="0">
@@ -9000,7 +9136,7 @@
           <a:ln/>
         </p:spPr>
         <p:txBody>
-          <a:bodyPr wrap="square" lIns="0" tIns="0" rIns="0" bIns="0" rtlCol="0" anchor="ctr"/>
+          <a:bodyPr wrap="square" lIns="0" tIns="0" rIns="0" bIns="0" rtlCol="0" anchor="t"/>
           <a:lstStyle/>
           <a:p>
             <a:pPr indent="0" marL="0">
@@ -9144,7 +9280,7 @@
           <a:ln/>
         </p:spPr>
         <p:txBody>
-          <a:bodyPr wrap="square" lIns="0" tIns="0" rIns="0" bIns="0" rtlCol="0" anchor="ctr"/>
+          <a:bodyPr wrap="square" lIns="0" tIns="0" rIns="0" bIns="0" rtlCol="0" anchor="t"/>
           <a:lstStyle/>
           <a:p>
             <a:pPr indent="0" marL="0">
@@ -9456,7 +9592,7 @@
           <a:ln/>
         </p:spPr>
         <p:txBody>
-          <a:bodyPr wrap="square" lIns="0" tIns="0" rIns="0" bIns="0" rtlCol="0" anchor="ctr"/>
+          <a:bodyPr wrap="square" lIns="0" tIns="0" rIns="0" bIns="0" rtlCol="0" anchor="t"/>
           <a:lstStyle/>
           <a:p>
             <a:pPr indent="0" marL="0">
@@ -9520,7 +9656,7 @@
           <a:ln/>
         </p:spPr>
         <p:txBody>
-          <a:bodyPr wrap="square" lIns="0" tIns="0" rIns="0" bIns="0" rtlCol="0" anchor="ctr"/>
+          <a:bodyPr wrap="square" lIns="0" tIns="0" rIns="0" bIns="0" rtlCol="0" anchor="t"/>
           <a:lstStyle/>
           <a:p>
             <a:pPr indent="0" marL="0">
@@ -9559,7 +9695,7 @@
           <a:ln/>
         </p:spPr>
         <p:txBody>
-          <a:bodyPr wrap="square" lIns="0" tIns="0" rIns="0" bIns="0" rtlCol="0" anchor="ctr"/>
+          <a:bodyPr wrap="square" lIns="0" tIns="0" rIns="0" bIns="0" rtlCol="0" anchor="t"/>
           <a:lstStyle/>
           <a:p>
             <a:pPr indent="0" marL="0">
@@ -9598,7 +9734,7 @@
           <a:ln/>
         </p:spPr>
         <p:txBody>
-          <a:bodyPr wrap="square" lIns="0" tIns="0" rIns="0" bIns="0" rtlCol="0" anchor="ctr"/>
+          <a:bodyPr wrap="square" lIns="0" tIns="0" rIns="0" bIns="0" rtlCol="0" anchor="t"/>
           <a:lstStyle/>
           <a:p>
             <a:pPr indent="0" marL="0">
@@ -9664,7 +9800,7 @@
           <a:ln/>
         </p:spPr>
         <p:txBody>
-          <a:bodyPr wrap="square" lIns="0" tIns="0" rIns="0" bIns="0" rtlCol="0" anchor="ctr"/>
+          <a:bodyPr wrap="square" lIns="0" tIns="0" rIns="0" bIns="0" rtlCol="0" anchor="t"/>
           <a:lstStyle/>
           <a:p>
             <a:pPr indent="0" marL="0">
@@ -9703,7 +9839,7 @@
           <a:ln/>
         </p:spPr>
         <p:txBody>
-          <a:bodyPr wrap="square" lIns="0" tIns="0" rIns="0" bIns="0" rtlCol="0" anchor="ctr"/>
+          <a:bodyPr wrap="square" lIns="0" tIns="0" rIns="0" bIns="0" rtlCol="0" anchor="t"/>
           <a:lstStyle/>
           <a:p>
             <a:pPr indent="0" marL="0">
@@ -9742,7 +9878,7 @@
           <a:ln/>
         </p:spPr>
         <p:txBody>
-          <a:bodyPr wrap="square" lIns="0" tIns="0" rIns="0" bIns="0" rtlCol="0" anchor="ctr"/>
+          <a:bodyPr wrap="square" lIns="0" tIns="0" rIns="0" bIns="0" rtlCol="0" anchor="t"/>
           <a:lstStyle/>
           <a:p>
             <a:pPr indent="0" marL="0">
@@ -9808,7 +9944,7 @@
           <a:ln/>
         </p:spPr>
         <p:txBody>
-          <a:bodyPr wrap="square" lIns="0" tIns="0" rIns="0" bIns="0" rtlCol="0" anchor="ctr"/>
+          <a:bodyPr wrap="square" lIns="0" tIns="0" rIns="0" bIns="0" rtlCol="0" anchor="t"/>
           <a:lstStyle/>
           <a:p>
             <a:pPr indent="0" marL="0">
@@ -9847,7 +9983,7 @@
           <a:ln/>
         </p:spPr>
         <p:txBody>
-          <a:bodyPr wrap="square" lIns="0" tIns="0" rIns="0" bIns="0" rtlCol="0" anchor="ctr"/>
+          <a:bodyPr wrap="square" lIns="0" tIns="0" rIns="0" bIns="0" rtlCol="0" anchor="t"/>
           <a:lstStyle/>
           <a:p>
             <a:pPr indent="0" marL="0">
@@ -9886,7 +10022,7 @@
           <a:ln/>
         </p:spPr>
         <p:txBody>
-          <a:bodyPr wrap="square" lIns="0" tIns="0" rIns="0" bIns="0" rtlCol="0" anchor="ctr"/>
+          <a:bodyPr wrap="square" lIns="0" tIns="0" rIns="0" bIns="0" rtlCol="0" anchor="t"/>
           <a:lstStyle/>
           <a:p>
             <a:pPr indent="0" marL="0">
@@ -9949,7 +10085,7 @@
           <a:ln/>
         </p:spPr>
         <p:txBody>
-          <a:bodyPr wrap="square" lIns="0" tIns="0" rIns="0" bIns="0" rtlCol="0" anchor="ctr"/>
+          <a:bodyPr wrap="square" lIns="0" tIns="0" rIns="0" bIns="0" rtlCol="0" anchor="t"/>
           <a:lstStyle/>
           <a:p>
             <a:pPr indent="0" marL="0">
@@ -10015,7 +10151,7 @@
           <a:ln/>
         </p:spPr>
         <p:txBody>
-          <a:bodyPr wrap="square" lIns="0" tIns="0" rIns="0" bIns="0" rtlCol="0" anchor="ctr"/>
+          <a:bodyPr wrap="square" lIns="0" tIns="0" rIns="0" bIns="0" rtlCol="0" anchor="t"/>
           <a:lstStyle/>
           <a:p>
             <a:pPr indent="0" marL="0">
@@ -10054,7 +10190,7 @@
           <a:ln/>
         </p:spPr>
         <p:txBody>
-          <a:bodyPr wrap="square" lIns="0" tIns="0" rIns="0" bIns="0" rtlCol="0" anchor="ctr"/>
+          <a:bodyPr wrap="square" lIns="0" tIns="0" rIns="0" bIns="0" rtlCol="0" anchor="t"/>
           <a:lstStyle/>
           <a:p>
             <a:pPr indent="0" marL="0">
@@ -10120,7 +10256,7 @@
           <a:ln/>
         </p:spPr>
         <p:txBody>
-          <a:bodyPr wrap="square" lIns="0" tIns="0" rIns="0" bIns="0" rtlCol="0" anchor="ctr"/>
+          <a:bodyPr wrap="square" lIns="0" tIns="0" rIns="0" bIns="0" rtlCol="0" anchor="t"/>
           <a:lstStyle/>
           <a:p>
             <a:pPr indent="0" marL="0">
@@ -10159,7 +10295,7 @@
           <a:ln/>
         </p:spPr>
         <p:txBody>
-          <a:bodyPr wrap="square" lIns="0" tIns="0" rIns="0" bIns="0" rtlCol="0" anchor="ctr"/>
+          <a:bodyPr wrap="square" lIns="0" tIns="0" rIns="0" bIns="0" rtlCol="0" anchor="t"/>
           <a:lstStyle/>
           <a:p>
             <a:pPr indent="0" marL="0">
@@ -10225,7 +10361,7 @@
           <a:ln/>
         </p:spPr>
         <p:txBody>
-          <a:bodyPr wrap="square" lIns="0" tIns="0" rIns="0" bIns="0" rtlCol="0" anchor="ctr"/>
+          <a:bodyPr wrap="square" lIns="0" tIns="0" rIns="0" bIns="0" rtlCol="0" anchor="t"/>
           <a:lstStyle/>
           <a:p>
             <a:pPr indent="0" marL="0">
@@ -10264,7 +10400,7 @@
           <a:ln/>
         </p:spPr>
         <p:txBody>
-          <a:bodyPr wrap="square" lIns="0" tIns="0" rIns="0" bIns="0" rtlCol="0" anchor="ctr"/>
+          <a:bodyPr wrap="square" lIns="0" tIns="0" rIns="0" bIns="0" rtlCol="0" anchor="t"/>
           <a:lstStyle/>
           <a:p>
             <a:pPr indent="0" marL="0">
@@ -10328,7 +10464,7 @@
           <a:ln/>
         </p:spPr>
         <p:txBody>
-          <a:bodyPr wrap="square" lIns="0" tIns="0" rIns="0" bIns="0" rtlCol="0" anchor="ctr"/>
+          <a:bodyPr wrap="square" lIns="0" tIns="0" rIns="0" bIns="0" rtlCol="0" anchor="t"/>
           <a:lstStyle/>
           <a:p>
             <a:pPr indent="0" marL="0">
@@ -10367,7 +10503,7 @@
           <a:ln/>
         </p:spPr>
         <p:txBody>
-          <a:bodyPr wrap="square" lIns="0" tIns="0" rIns="0" bIns="0" rtlCol="0" anchor="ctr"/>
+          <a:bodyPr wrap="square" lIns="0" tIns="0" rIns="0" bIns="0" rtlCol="0" anchor="t"/>
           <a:lstStyle/>
           <a:p>
             <a:pPr indent="0" marL="0">
@@ -10433,7 +10569,7 @@
           <a:ln/>
         </p:spPr>
         <p:txBody>
-          <a:bodyPr wrap="square" lIns="0" tIns="0" rIns="0" bIns="0" rtlCol="0" anchor="ctr"/>
+          <a:bodyPr wrap="square" lIns="0" tIns="0" rIns="0" bIns="0" rtlCol="0" anchor="t"/>
           <a:lstStyle/>
           <a:p>
             <a:pPr indent="0" marL="0">
@@ -10472,7 +10608,7 @@
           <a:ln/>
         </p:spPr>
         <p:txBody>
-          <a:bodyPr wrap="square" lIns="0" tIns="0" rIns="0" bIns="0" rtlCol="0" anchor="ctr"/>
+          <a:bodyPr wrap="square" lIns="0" tIns="0" rIns="0" bIns="0" rtlCol="0" anchor="t"/>
           <a:lstStyle/>
           <a:p>
             <a:pPr indent="0" marL="0">
@@ -10511,7 +10647,7 @@
           <a:ln/>
         </p:spPr>
         <p:txBody>
-          <a:bodyPr wrap="square" lIns="0" tIns="0" rIns="0" bIns="0" rtlCol="0" anchor="ctr"/>
+          <a:bodyPr wrap="square" lIns="0" tIns="0" rIns="0" bIns="0" rtlCol="0" anchor="t"/>
           <a:lstStyle/>
           <a:p>
             <a:pPr indent="0" marL="0">
@@ -10550,7 +10686,7 @@
           <a:ln/>
         </p:spPr>
         <p:txBody>
-          <a:bodyPr wrap="square" lIns="0" tIns="0" rIns="0" bIns="0" rtlCol="0" anchor="ctr"/>
+          <a:bodyPr wrap="square" lIns="0" tIns="0" rIns="0" bIns="0" rtlCol="0" anchor="t"/>
           <a:lstStyle/>
           <a:p>
             <a:pPr indent="0" marL="0">
@@ -10616,7 +10752,7 @@
           <a:ln/>
         </p:spPr>
         <p:txBody>
-          <a:bodyPr wrap="square" lIns="0" tIns="0" rIns="0" bIns="0" rtlCol="0" anchor="ctr"/>
+          <a:bodyPr wrap="square" lIns="0" tIns="0" rIns="0" bIns="0" rtlCol="0" anchor="t"/>
           <a:lstStyle/>
           <a:p>
             <a:pPr indent="0" marL="0">
@@ -10655,7 +10791,7 @@
           <a:ln/>
         </p:spPr>
         <p:txBody>
-          <a:bodyPr wrap="square" lIns="0" tIns="0" rIns="0" bIns="0" rtlCol="0" anchor="ctr"/>
+          <a:bodyPr wrap="square" lIns="0" tIns="0" rIns="0" bIns="0" rtlCol="0" anchor="t"/>
           <a:lstStyle/>
           <a:p>
             <a:pPr indent="0" marL="0">
@@ -10806,7 +10942,7 @@
           <a:ln/>
         </p:spPr>
         <p:txBody>
-          <a:bodyPr wrap="square" lIns="0" tIns="0" rIns="0" bIns="0" rtlCol="0" anchor="ctr"/>
+          <a:bodyPr wrap="square" lIns="0" tIns="0" rIns="0" bIns="0" rtlCol="0" anchor="t"/>
           <a:lstStyle/>
           <a:p>
             <a:pPr indent="0" marL="0">
@@ -10845,7 +10981,7 @@
           <a:ln/>
         </p:spPr>
         <p:txBody>
-          <a:bodyPr wrap="square" lIns="0" tIns="0" rIns="0" bIns="0" rtlCol="0" anchor="ctr"/>
+          <a:bodyPr wrap="square" lIns="0" tIns="0" rIns="0" bIns="0" rtlCol="0" anchor="t"/>
           <a:lstStyle/>
           <a:p>
             <a:pPr indent="0" marL="0">
@@ -11016,7 +11152,7 @@
           <a:ln/>
         </p:spPr>
         <p:txBody>
-          <a:bodyPr wrap="square" lIns="0" tIns="0" rIns="0" bIns="0" rtlCol="0" anchor="ctr"/>
+          <a:bodyPr wrap="square" lIns="0" tIns="0" rIns="0" bIns="0" rtlCol="0" anchor="t"/>
           <a:lstStyle/>
           <a:p>
             <a:pPr indent="0" marL="0">

</xml_diff>